<commit_message>
Slides: descriptive alt text for chart images; set document author
</commit_message>
<xml_diff>
--- a/APT_Detection_MidEval.pptx
+++ b/APT_Detection_MidEval.pptx
@@ -17601,7 +17601,7 @@
       </p:sp>
       <p:pic>
         <p:nvPicPr>
-          <p:cNvPr id="20" name="Image 0" descr="/private/tmp/claude-501/-Users-ashishjain-Documents-RIS-Mid-Eval/4e14a31e-25f5-4016-81db-47057b986f0d/scratchpad/deck/charts/f1_protocols.png">    </p:cNvPr>
+          <p:cNvPr id="20" name="Image 0" descr="F1-score of all 15 models under the paper protocol and the leakage-free protocol">    </p:cNvPr>
           <p:cNvPicPr>
             <a:picLocks noChangeAspect="1"/>
           </p:cNvPicPr>
@@ -21367,7 +21367,7 @@
       </p:sp>
       <p:pic>
         <p:nvPicPr>
-          <p:cNvPr id="20" name="Image 0" descr="/private/tmp/claude-501/-Users-ashishjain-Documents-RIS-Mid-Eval/4e14a31e-25f5-4016-81db-47057b986f0d/scratchpad/deck/charts/stage_confusion.png">    </p:cNvPr>
+          <p:cNvPr id="20" name="Image 0" descr="Confusion matrix of APT-stage predictions by the soft-vote hybrid">    </p:cNvPr>
           <p:cNvPicPr>
             <a:picLocks noChangeAspect="1"/>
           </p:cNvPicPr>
@@ -23793,7 +23793,7 @@
       </p:sp>
       <p:pic>
         <p:nvPicPr>
-          <p:cNvPr id="27" name="Image 0" descr="/private/tmp/claude-501/-Users-ashishjain-Documents-RIS-Mid-Eval/4e14a31e-25f5-4016-81db-47057b986f0d/scratchpad/deck/charts/missed_by_activity.png">    </p:cNvPr>
+          <p:cNvPr id="27" name="Image 0" descr="Share of APT flows missed by the hybrid, by attack activity">    </p:cNvPr>
           <p:cNvPicPr>
             <a:picLocks noChangeAspect="1"/>
           </p:cNvPicPr>
@@ -41715,7 +41715,7 @@
       </p:sp>
       <p:pic>
         <p:nvPicPr>
-          <p:cNvPr id="28" name="Image 0" descr="/private/tmp/claude-501/-Users-ashishjain-Documents-RIS-Mid-Eval/4e14a31e-25f5-4016-81db-47057b986f0d/scratchpad/deck/charts/stage_counts.png">    </p:cNvPr>
+          <p:cNvPr id="28" name="Image 0" descr="Bar chart of DAPT2020 flows per APT stage after cleaning, log scale">    </p:cNvPr>
           <p:cNvPicPr>
             <a:picLocks noChangeAspect="1"/>
           </p:cNvPicPr>

</xml_diff>

<commit_message>
Slides: add presenters to title slide; three-speaker hand-offs in notes
</commit_message>
<xml_diff>
--- a/APT_Detection_MidEval.pptx
+++ b/APT_Detection_MidEval.pptx
@@ -527,7 +527,7 @@
             <a:r>
               <a:rPr lang="en-US" dirty="0"/>
               <a:t>[ 0:40 on this slide  |  clock 0:00 -&gt; 0:40 of 20:00 ]
-Good morning. We are presenting Project 16: anomaly detection using machine learning for Advanced Persistent Threats, or APTs.
+Good morning. We are Ashish Jain, Ameya Purohit and Chaitanya Shah, and we are presenting Project 16: anomaly detection using machine learning for Advanced Persistent Threats, or APTs.
 Our reference paper is Saini and colleagues, published in 2023 in Concurrency and Computation: Practice and Experience. It proposes a hybrid Random Forest plus XGBoost model for detecting APT attacks.
 In this mid-term evaluation we will show that we implemented the complete method, moved it to a dataset that genuinely contains APT attacks, and tested whether the paper's claims hold up.
 TRANSITION: Here is how the talk is organised.</a:t>
@@ -900,8 +900,7 @@
               <a:rPr lang="en-US" dirty="0"/>
               <a:t>[ 0:40 on this slide  |  clock 10:45 -&gt; 11:25 of 20:00 ]
 Three experiments. A replication with exactly the paper's protocol. A correction: the same pipeline, leakage-free, repeated over five random seeds for the key models. And an extension the paper's datasets cannot support: predicting the APT stage of each flow.
-Fifteen models in total: the hybrid as published, a soft-vote variant, ten classical models and three deep learning models.
-HAND-OFF POINT (next speaker): results.</a:t>
+Fifteen models in total: the hybrid as published, a soft-vote variant, ten classical models and three deep learning models.</a:t>
             </a:r>
             <a:endParaRPr lang="en-US" dirty="0"/>
           </a:p>
@@ -1175,7 +1174,8 @@
 On the left, as the paper would report it: F1 97.06 percent. Same predictions at the real ratio: 91.49. So 5.6 of the 8.2 points come purely from testing on a fifty-fifty set: precision drops from 94.8 to 84.7 percent.
 The remaining 2.6 points are the leak: 70 percent of the APT flows in the paper's test set are synthetic, and the model misses only 0.34 percent of those, versus 1.12 percent of real ones.
 Both effects come from balancing before splitting; the misleading class ratio accounts for about 68 percent of the gap, leakage for the rest.
-TRANSITION: Is this specific to the hybrid? Here are all fifteen models.</a:t>
+TRANSITION: Is this specific to the hybrid? Here are all fifteen models.
+HAND-OFF POINT (Speaker 3, from 13:50): remaining results, conclusions and Q&amp;A.</a:t>
             </a:r>
             <a:endParaRPr lang="en-US" dirty="0"/>
           </a:p>
@@ -1631,8 +1631,7 @@
               <a:rPr lang="en-US" dirty="0"/>
               <a:t>[ 1:00 on this slide  |  clock 16:55 -&gt; 17:55 of 20:00 ]
 False alarms first. 50.6 percent of them are flows labelled benign that involve the attacker's own hosts. That may be label noise, but it's not proof: those hosts also appear on Monday, when no attacks are labelled. And 42.2 percent of false alarms fall on Monday itself, so they are genuine false alarms on normal traffic.
-Missed attacks, on the right. Rare, low-volume steps such as CSRF, command injection, privilege escalation and SQL injection have the highest miss rates. But by count, most misses are Account Discovery: 57 of 127. That is a clear target for improvement.
-HAND-OFF POINT (next speaker): conclusions.</a:t>
+Missed attacks, on the right. Rare, low-volume steps such as CSRF, command injection, privilege escalation and SQL injection have the highest miss rates. But by count, most misses are Account Discovery: 57 of 127. That is a clear target for improvement.</a:t>
             </a:r>
             <a:endParaRPr lang="en-US" dirty="0"/>
           </a:p>
@@ -2464,8 +2463,7 @@
 This table compares the paper's datasets, on the left, with the one we used, on the right.
 None of the paper's datasets was built around an APT campaign, and none labels flows with an APT stage. Their attacks are generic and isolated: DoS, brute force, botnets, probes, exploits. NSL-KDD is even based on traffic from 1998.
 DAPT2020 was published in 2020 by researchers at Arizona State University specifically for APT research. A red team ran a full campaign over five days, and every flow is labelled with its stage.
-Crucially, it uses the same 76 CICFlowMeter features as CIC-IDS2017 and 2018, the paper's main datasets, so the paper's method runs on it unchanged and our results are directly comparable.
-HAND-OFF POINT (next speaker): data and method.</a:t>
+Crucially, it uses the same 76 CICFlowMeter features as CIC-IDS2017 and 2018, the paper's main datasets, so the paper's method runs on it unchanged and our results are directly comparable.</a:t>
             </a:r>
             <a:endParaRPr lang="en-US" dirty="0"/>
           </a:p>
@@ -2739,7 +2737,8 @@
 The most serious: one of the ten CSV files has no header row. A standard loader treats its first flow as the header, which loses 2,314 flows: 94 percent of all Lateral Movement.
 Second, benign traffic is labelled in three different ways, which we unified. Third, 5,248 duplicate flows and 12 constant columns, removed as the paper prescribes. Fourth, only 15 exfiltration flows.
 Sanity check: after the fix we count 63,712 benign flows, which matches the figure other researchers report for DAPT2020.
-TRANSITION: With clean data, we implemented the paper's pipeline.</a:t>
+TRANSITION: With clean data, we implemented the paper's pipeline.
+HAND-OFF POINT (Speaker 2, from 7:05): pipeline, hybrid model, experiments and the first two results.</a:t>
             </a:r>
             <a:endParaRPr lang="en-US" dirty="0"/>
           </a:p>
@@ -5055,7 +5054,7 @@
         </p:nvSpPr>
         <p:spPr>
           <a:xfrm>
-            <a:off x="685800" y="1097280"/>
+            <a:off x="685800" y="777240"/>
             <a:ext cx="6035040" cy="274320"/>
           </a:xfrm>
           <a:prstGeom prst="rect">
@@ -5094,8 +5093,8 @@
         </p:nvSpPr>
         <p:spPr>
           <a:xfrm>
-            <a:off x="685800" y="1554480"/>
-            <a:ext cx="6035040" cy="2514600"/>
+            <a:off x="685800" y="1188720"/>
+            <a:ext cx="6035040" cy="2377440"/>
           </a:xfrm>
           <a:prstGeom prst="rect">
             <a:avLst/>
@@ -5133,8 +5132,8 @@
         </p:nvSpPr>
         <p:spPr>
           <a:xfrm>
-            <a:off x="685800" y="4206240"/>
-            <a:ext cx="5760720" cy="868680"/>
+            <a:off x="685800" y="3657600"/>
+            <a:ext cx="5760720" cy="777240"/>
           </a:xfrm>
           <a:prstGeom prst="rect">
             <a:avLst/>
@@ -5172,7 +5171,179 @@
         </p:nvSpPr>
         <p:spPr>
           <a:xfrm>
-            <a:off x="685800" y="5715000"/>
+            <a:off x="685800" y="4617720"/>
+            <a:ext cx="3657600" cy="228600"/>
+          </a:xfrm>
+          <a:prstGeom prst="rect">
+            <a:avLst/>
+          </a:prstGeom>
+          <a:noFill/>
+          <a:ln/>
+        </p:spPr>
+        <p:txBody>
+          <a:bodyPr wrap="square" lIns="0" tIns="0" rIns="0" bIns="0" rtlCol="0" anchor="t"/>
+          <a:lstStyle/>
+          <a:p>
+            <a:pPr indent="0" marL="0">
+              <a:buNone/>
+            </a:pPr>
+            <a:r>
+              <a:rPr lang="en-US" sz="1000" b="1" dirty="0">
+                <a:solidFill>
+                  <a:srgbClr val="F08A6E"/>
+                </a:solidFill>
+                <a:latin typeface="Arial" pitchFamily="34" charset="0"/>
+                <a:ea typeface="Arial" pitchFamily="34" charset="-122"/>
+                <a:cs typeface="Arial" pitchFamily="34" charset="-120"/>
+              </a:rPr>
+              <a:t>PRESENTED BY</a:t>
+            </a:r>
+            <a:endParaRPr lang="en-US" sz="1000" dirty="0"/>
+          </a:p>
+        </p:txBody>
+      </p:sp>
+      <p:sp>
+        <p:nvSpPr>
+          <p:cNvPr id="86" name="Text 84"/>
+          <p:cNvSpPr txBox="1"/>
+          <p:nvPr/>
+        </p:nvSpPr>
+        <p:spPr>
+          <a:xfrm>
+            <a:off x="685800" y="4892040"/>
+            <a:ext cx="5486400" cy="868680"/>
+          </a:xfrm>
+          <a:prstGeom prst="rect">
+            <a:avLst/>
+          </a:prstGeom>
+          <a:noFill/>
+          <a:ln/>
+        </p:spPr>
+        <p:txBody>
+          <a:bodyPr wrap="square" lIns="0" tIns="0" rIns="0" bIns="0" rtlCol="0" anchor="t"/>
+          <a:lstStyle/>
+          <a:p>
+            <a:pPr indent="0" marL="0">
+              <a:spcAft>
+                <a:spcPts val="200"/>
+              </a:spcAft>
+              <a:buNone/>
+            </a:pPr>
+            <a:r>
+              <a:rPr lang="en-US" sz="1400" b="1" dirty="0">
+                <a:solidFill>
+                  <a:srgbClr val="FFFFFF"/>
+                </a:solidFill>
+                <a:latin typeface="Arial" pitchFamily="34" charset="0"/>
+                <a:ea typeface="Arial" pitchFamily="34" charset="-122"/>
+                <a:cs typeface="Arial" pitchFamily="34" charset="-120"/>
+              </a:rPr>
+              <a:t>Ashish Jain</a:t>
+            </a:r>
+            <a:pPr indent="0" marL="0">
+              <a:spcAft>
+                <a:spcPts val="200"/>
+              </a:spcAft>
+              <a:buNone/>
+            </a:pPr>
+            <a:r>
+              <a:rPr lang="en-US" sz="1400" dirty="0">
+                <a:solidFill>
+                  <a:srgbClr val="A9B6C8"/>
+                </a:solidFill>
+                <a:latin typeface="Arial" pitchFamily="34" charset="0"/>
+                <a:ea typeface="Arial" pitchFamily="34" charset="-122"/>
+                <a:cs typeface="Arial" pitchFamily="34" charset="-120"/>
+              </a:rPr>
+              <a:t>   (2025202029)</a:t>
+            </a:r>
+            <a:endParaRPr lang="en-US" sz="1400" dirty="0"/>
+          </a:p>
+          <a:p>
+            <a:pPr indent="0" marL="0">
+              <a:spcAft>
+                <a:spcPts val="200"/>
+              </a:spcAft>
+              <a:buNone/>
+            </a:pPr>
+            <a:r>
+              <a:rPr lang="en-US" sz="1400" b="1" dirty="0">
+                <a:solidFill>
+                  <a:srgbClr val="FFFFFF"/>
+                </a:solidFill>
+                <a:latin typeface="Arial" pitchFamily="34" charset="0"/>
+                <a:ea typeface="Arial" pitchFamily="34" charset="-122"/>
+                <a:cs typeface="Arial" pitchFamily="34" charset="-120"/>
+              </a:rPr>
+              <a:t>Ameya Purohit</a:t>
+            </a:r>
+            <a:pPr indent="0" marL="0">
+              <a:spcAft>
+                <a:spcPts val="200"/>
+              </a:spcAft>
+              <a:buNone/>
+            </a:pPr>
+            <a:r>
+              <a:rPr lang="en-US" sz="1400" dirty="0">
+                <a:solidFill>
+                  <a:srgbClr val="A9B6C8"/>
+                </a:solidFill>
+                <a:latin typeface="Arial" pitchFamily="34" charset="0"/>
+                <a:ea typeface="Arial" pitchFamily="34" charset="-122"/>
+                <a:cs typeface="Arial" pitchFamily="34" charset="-120"/>
+              </a:rPr>
+              <a:t>   (2025202006)</a:t>
+            </a:r>
+            <a:endParaRPr lang="en-US" sz="1400" dirty="0"/>
+          </a:p>
+          <a:p>
+            <a:pPr indent="0" marL="0">
+              <a:spcAft>
+                <a:spcPts val="200"/>
+              </a:spcAft>
+              <a:buNone/>
+            </a:pPr>
+            <a:r>
+              <a:rPr lang="en-US" sz="1400" b="1" dirty="0">
+                <a:solidFill>
+                  <a:srgbClr val="FFFFFF"/>
+                </a:solidFill>
+                <a:latin typeface="Arial" pitchFamily="34" charset="0"/>
+                <a:ea typeface="Arial" pitchFamily="34" charset="-122"/>
+                <a:cs typeface="Arial" pitchFamily="34" charset="-120"/>
+              </a:rPr>
+              <a:t>Chaitanya Shah</a:t>
+            </a:r>
+            <a:pPr indent="0" marL="0">
+              <a:spcAft>
+                <a:spcPts val="200"/>
+              </a:spcAft>
+              <a:buNone/>
+            </a:pPr>
+            <a:r>
+              <a:rPr lang="en-US" sz="1400" dirty="0">
+                <a:solidFill>
+                  <a:srgbClr val="A9B6C8"/>
+                </a:solidFill>
+                <a:latin typeface="Arial" pitchFamily="34" charset="0"/>
+                <a:ea typeface="Arial" pitchFamily="34" charset="-122"/>
+                <a:cs typeface="Arial" pitchFamily="34" charset="-120"/>
+              </a:rPr>
+              <a:t>   (2025202033)</a:t>
+            </a:r>
+            <a:endParaRPr lang="en-US" sz="1400" dirty="0"/>
+          </a:p>
+        </p:txBody>
+      </p:sp>
+      <p:sp>
+        <p:nvSpPr>
+          <p:cNvPr id="87" name="Text 85"/>
+          <p:cNvSpPr txBox="1"/>
+          <p:nvPr/>
+        </p:nvSpPr>
+        <p:spPr>
+          <a:xfrm>
+            <a:off x="685800" y="5989320"/>
             <a:ext cx="5852160" cy="502920"/>
           </a:xfrm>
           <a:prstGeom prst="rect">

</xml_diff>